<commit_message>
Fix poster text clipping by computing box heights instead of guessing
Opening the built file in PowerPoint showed five text blocks clipped mid-
sentence. Autofit is deliberately off, so PowerPoint does not shrink text to
compensate, it simply cuts it off, and the boxes had been sized by eye.

- added fit_height(): estimates the height a block actually needs from its
  character count, font size, box width, line spacing and paragraph spacing.
  Every prose box and figure caption is now sized from it
- figure heights are read from each image's real aspect ratio rather than
  hardcoded, so they cannot go stale when a figure is regenerated
- figure 2 rebuilt shorter (4.85 in rather than 5.60) to recover column height
- trimmed the Results body, which needed 4.88 in against 4.20 allocated
- all three columns now end above the 26.50 in margin: 25.74 / 26.41 / 25.11
- 628 words, smallest type 19 pt
</commit_message>
<xml_diff>
--- a/figures/Oughton_Avilash_Angirekula_2026ASSIP_Poster.pptx
+++ b/figures/Oughton_Avilash_Angirekula_2026ASSIP_Poster.pptx
@@ -5355,7 +5355,7 @@
         <p:spPr>
           <a:xfrm>
             <a:off x="457200" y="5486400"/>
-            <a:ext cx="10332720" cy="5669280"/>
+            <a:ext cx="10332720" cy="5474207"/>
           </a:xfrm>
           <a:prstGeom prst="rect">
             <a:avLst/>
@@ -5559,7 +5559,7 @@
         <p:spPr>
           <a:xfrm>
             <a:off x="457200" y="12710159"/>
-            <a:ext cx="10332720" cy="2880360"/>
+            <a:ext cx="10332720" cy="2855468"/>
           </a:xfrm>
           <a:prstGeom prst="rect">
             <a:avLst/>
@@ -5638,7 +5638,7 @@
         </p:nvSpPr>
         <p:spPr>
           <a:xfrm>
-            <a:off x="548640" y="15499080"/>
+            <a:off x="548640" y="15565627"/>
             <a:ext cx="10149840" cy="713232"/>
           </a:xfrm>
           <a:prstGeom prst="rect">
@@ -5684,7 +5684,7 @@
         </p:nvSpPr>
         <p:spPr>
           <a:xfrm>
-            <a:off x="685800" y="15553943"/>
+            <a:off x="685800" y="15620491"/>
             <a:ext cx="3017520" cy="603504"/>
           </a:xfrm>
           <a:prstGeom prst="rect">
@@ -5726,7 +5726,7 @@
         </p:nvSpPr>
         <p:spPr>
           <a:xfrm>
-            <a:off x="3703320" y="15553943"/>
+            <a:off x="3703320" y="15620491"/>
             <a:ext cx="6812280" cy="603504"/>
           </a:xfrm>
           <a:prstGeom prst="rect">
@@ -5768,7 +5768,7 @@
         </p:nvSpPr>
         <p:spPr>
           <a:xfrm>
-            <a:off x="548640" y="16322039"/>
+            <a:off x="548640" y="16388587"/>
             <a:ext cx="10149840" cy="713232"/>
           </a:xfrm>
           <a:prstGeom prst="rect">
@@ -5814,7 +5814,7 @@
         </p:nvSpPr>
         <p:spPr>
           <a:xfrm>
-            <a:off x="685800" y="16376903"/>
+            <a:off x="685800" y="16443451"/>
             <a:ext cx="3017520" cy="603504"/>
           </a:xfrm>
           <a:prstGeom prst="rect">
@@ -5856,7 +5856,7 @@
         </p:nvSpPr>
         <p:spPr>
           <a:xfrm>
-            <a:off x="3703320" y="16376903"/>
+            <a:off x="3703320" y="16443451"/>
             <a:ext cx="6812280" cy="603504"/>
           </a:xfrm>
           <a:prstGeom prst="rect">
@@ -5898,7 +5898,7 @@
         </p:nvSpPr>
         <p:spPr>
           <a:xfrm>
-            <a:off x="548640" y="17144999"/>
+            <a:off x="548640" y="17211547"/>
             <a:ext cx="10149840" cy="713232"/>
           </a:xfrm>
           <a:prstGeom prst="rect">
@@ -5944,7 +5944,7 @@
         </p:nvSpPr>
         <p:spPr>
           <a:xfrm>
-            <a:off x="685800" y="17199863"/>
+            <a:off x="685800" y="17266411"/>
             <a:ext cx="3017520" cy="603504"/>
           </a:xfrm>
           <a:prstGeom prst="rect">
@@ -5986,7 +5986,7 @@
         </p:nvSpPr>
         <p:spPr>
           <a:xfrm>
-            <a:off x="3703320" y="17199863"/>
+            <a:off x="3703320" y="17266411"/>
             <a:ext cx="6812280" cy="603504"/>
           </a:xfrm>
           <a:prstGeom prst="rect">
@@ -6028,7 +6028,7 @@
         </p:nvSpPr>
         <p:spPr>
           <a:xfrm>
-            <a:off x="548640" y="17967959"/>
+            <a:off x="548640" y="18034507"/>
             <a:ext cx="10149840" cy="713232"/>
           </a:xfrm>
           <a:prstGeom prst="rect">
@@ -6074,7 +6074,7 @@
         </p:nvSpPr>
         <p:spPr>
           <a:xfrm>
-            <a:off x="685800" y="18022823"/>
+            <a:off x="685800" y="18089371"/>
             <a:ext cx="3017520" cy="603504"/>
           </a:xfrm>
           <a:prstGeom prst="rect">
@@ -6116,7 +6116,7 @@
         </p:nvSpPr>
         <p:spPr>
           <a:xfrm>
-            <a:off x="3703320" y="18022823"/>
+            <a:off x="3703320" y="18089371"/>
             <a:ext cx="6812280" cy="603504"/>
           </a:xfrm>
           <a:prstGeom prst="rect">
@@ -6158,8 +6158,8 @@
         </p:nvSpPr>
         <p:spPr>
           <a:xfrm>
-            <a:off x="457200" y="18882359"/>
-            <a:ext cx="10332720" cy="3108960"/>
+            <a:off x="457200" y="18948907"/>
+            <a:ext cx="10332720" cy="1925827"/>
           </a:xfrm>
           <a:prstGeom prst="rect">
             <a:avLst/>
@@ -6200,8 +6200,8 @@
         </p:nvSpPr>
         <p:spPr>
           <a:xfrm>
-            <a:off x="457200" y="22128479"/>
-            <a:ext cx="10332720" cy="2103120"/>
+            <a:off x="457200" y="21103335"/>
+            <a:ext cx="10332720" cy="2434844"/>
           </a:xfrm>
           <a:prstGeom prst="rect">
             <a:avLst/>
@@ -6246,8 +6246,8 @@
         </p:nvSpPr>
         <p:spPr>
           <a:xfrm>
-            <a:off x="457200" y="22128479"/>
-            <a:ext cx="128016" cy="2103120"/>
+            <a:off x="457200" y="21103335"/>
+            <a:ext cx="128016" cy="2434844"/>
           </a:xfrm>
           <a:prstGeom prst="rect">
             <a:avLst/>
@@ -6290,8 +6290,8 @@
         </p:nvSpPr>
         <p:spPr>
           <a:xfrm>
-            <a:off x="685800" y="22183343"/>
-            <a:ext cx="9921240" cy="1993392"/>
+            <a:off x="685800" y="21158199"/>
+            <a:ext cx="9921240" cy="2306828"/>
           </a:xfrm>
           <a:prstGeom prst="rect">
             <a:avLst/>
@@ -6811,8 +6811,8 @@
         </p:nvSpPr>
         <p:spPr>
           <a:xfrm>
-            <a:off x="11292840" y="7040880"/>
-            <a:ext cx="10332720" cy="1097280"/>
+            <a:off x="11292840" y="6931152"/>
+            <a:ext cx="10332720" cy="1358773"/>
           </a:xfrm>
           <a:prstGeom prst="rect">
             <a:avLst/>
@@ -6861,7 +6861,7 @@
         </p:blipFill>
         <p:spPr>
           <a:xfrm>
-            <a:off x="11292840" y="8229600"/>
+            <a:off x="11292840" y="8399653"/>
             <a:ext cx="10332720" cy="4307742"/>
           </a:xfrm>
           <a:prstGeom prst="rect">
@@ -6877,8 +6877,8 @@
         </p:nvSpPr>
         <p:spPr>
           <a:xfrm>
-            <a:off x="11292840" y="12673584"/>
-            <a:ext cx="10332720" cy="960120"/>
+            <a:off x="11292840" y="12844555"/>
+            <a:ext cx="10332720" cy="815847"/>
           </a:xfrm>
           <a:prstGeom prst="rect">
             <a:avLst/>
@@ -6919,8 +6919,8 @@
         </p:nvSpPr>
         <p:spPr>
           <a:xfrm>
-            <a:off x="11292840" y="13679424"/>
-            <a:ext cx="10332720" cy="3840480"/>
+            <a:off x="11292840" y="13751843"/>
+            <a:ext cx="10332720" cy="4460748"/>
           </a:xfrm>
           <a:prstGeom prst="rect">
             <a:avLst/>
@@ -6948,7 +6948,7 @@
                 </a:solidFill>
                 <a:latin typeface="Arial"/>
               </a:rPr>
-              <a:t>Of 2,696 facilities, 1,742 face no mapped hazard and 205 face two or more. Eighteen states holding half the national fleet sit below 10% exposed, while ten states holding a third sit above 60%. Almost nothing falls in between.</a:t>
+              <a:t>Of 2,696 facilities, 1,742 face no mapped hazard and 205 face two or more. Eighteen states holding half the fleet sit below 10% exposed. Ten states holding a third sit above 60%.</a:t>
             </a:r>
           </a:p>
           <a:p>
@@ -6986,7 +6986,7 @@
                 </a:solidFill>
                 <a:latin typeface="Arial"/>
               </a:rPr>
-              <a:t>Virginia, the largest concentration on Earth with 409 facilities, is 0.7% exposed. California and New Jersey are 100%.</a:t>
+              <a:t>Virginia, the largest concentration on Earth, is 0.7% exposed. California and New Jersey are 100%.</a:t>
             </a:r>
           </a:p>
           <a:p>
@@ -7024,7 +7024,7 @@
                 </a:solidFill>
                 <a:latin typeface="Arial"/>
               </a:rPr>
-              <a:t>Water stress is the exception that does reach Virginia: 952 facilities nationally sit in high or extremely-high stress basins, a binding constraint for evaporative cooling.</a:t>
+              <a:t>Water stress is the exception that reaches Virginia. 952 facilities nationally sit in high or extremely-high stress basins.</a:t>
             </a:r>
           </a:p>
         </p:txBody>
@@ -7045,8 +7045,8 @@
         </p:blipFill>
         <p:spPr>
           <a:xfrm>
-            <a:off x="11292840" y="17611344"/>
-            <a:ext cx="10332720" cy="5491236"/>
+            <a:off x="11292840" y="18322319"/>
+            <a:ext cx="10332720" cy="4874805"/>
           </a:xfrm>
           <a:prstGeom prst="rect">
             <a:avLst/>
@@ -7061,8 +7061,8 @@
         </p:nvSpPr>
         <p:spPr>
           <a:xfrm>
-            <a:off x="11292840" y="23244048"/>
-            <a:ext cx="10332720" cy="868680"/>
+            <a:off x="11292840" y="23334283"/>
+            <a:ext cx="10332720" cy="815847"/>
           </a:xfrm>
           <a:prstGeom prst="rect">
             <a:avLst/>
@@ -7190,7 +7190,7 @@
         <p:spPr>
           <a:xfrm>
             <a:off x="22128480" y="5486400"/>
-            <a:ext cx="10332720" cy="3977639"/>
+            <a:ext cx="10332720" cy="4582033"/>
           </a:xfrm>
           <a:prstGeom prst="rect">
             <a:avLst/>
@@ -7345,8 +7345,8 @@
         </p:nvSpPr>
         <p:spPr>
           <a:xfrm>
-            <a:off x="22128480" y="9555480"/>
-            <a:ext cx="10332720" cy="2240280"/>
+            <a:off x="22128480" y="10178161"/>
+            <a:ext cx="10332720" cy="2175002"/>
           </a:xfrm>
           <a:prstGeom prst="rect">
             <a:avLst/>
@@ -7391,8 +7391,8 @@
         </p:nvSpPr>
         <p:spPr>
           <a:xfrm>
-            <a:off x="22128480" y="9555480"/>
-            <a:ext cx="128016" cy="2240280"/>
+            <a:off x="22128480" y="10178161"/>
+            <a:ext cx="128016" cy="2175002"/>
           </a:xfrm>
           <a:prstGeom prst="rect">
             <a:avLst/>
@@ -7435,8 +7435,8 @@
         </p:nvSpPr>
         <p:spPr>
           <a:xfrm>
-            <a:off x="22357080" y="9628632"/>
-            <a:ext cx="9921240" cy="2093976"/>
+            <a:off x="22357080" y="10251313"/>
+            <a:ext cx="9921240" cy="2028698"/>
           </a:xfrm>
           <a:prstGeom prst="rect">
             <a:avLst/>
@@ -7504,7 +7504,7 @@
         </p:blipFill>
         <p:spPr>
           <a:xfrm>
-            <a:off x="22128480" y="11932919"/>
+            <a:off x="22128480" y="12481179"/>
             <a:ext cx="10332720" cy="3880657"/>
           </a:xfrm>
           <a:prstGeom prst="rect">
@@ -7520,8 +7520,8 @@
         </p:nvSpPr>
         <p:spPr>
           <a:xfrm>
-            <a:off x="22128480" y="15919704"/>
-            <a:ext cx="10332720" cy="960120"/>
+            <a:off x="22128480" y="16471563"/>
+            <a:ext cx="10332720" cy="815847"/>
           </a:xfrm>
           <a:prstGeom prst="rect">
             <a:avLst/>
@@ -7562,7 +7562,7 @@
         </p:nvSpPr>
         <p:spPr>
           <a:xfrm>
-            <a:off x="22128480" y="16971264"/>
+            <a:off x="22128480" y="16471563"/>
             <a:ext cx="10332720" cy="868680"/>
           </a:xfrm>
           <a:prstGeom prst="rect">
@@ -7606,7 +7606,7 @@
         </p:nvSpPr>
         <p:spPr>
           <a:xfrm>
-            <a:off x="22311360" y="17026127"/>
+            <a:off x="22311360" y="16526427"/>
             <a:ext cx="10058400" cy="777240"/>
           </a:xfrm>
           <a:prstGeom prst="rect">
@@ -7648,8 +7648,8 @@
         </p:nvSpPr>
         <p:spPr>
           <a:xfrm>
-            <a:off x="22128480" y="17931384"/>
-            <a:ext cx="10332720" cy="2331720"/>
+            <a:off x="22128480" y="17431683"/>
+            <a:ext cx="10332720" cy="2699258"/>
           </a:xfrm>
           <a:prstGeom prst="rect">
             <a:avLst/>
@@ -7766,7 +7766,7 @@
         </p:nvSpPr>
         <p:spPr>
           <a:xfrm>
-            <a:off x="22128480" y="20327112"/>
+            <a:off x="22128480" y="20240669"/>
             <a:ext cx="10332720" cy="868680"/>
           </a:xfrm>
           <a:prstGeom prst="rect">
@@ -7810,7 +7810,7 @@
         </p:nvSpPr>
         <p:spPr>
           <a:xfrm>
-            <a:off x="22311360" y="20381976"/>
+            <a:off x="22311360" y="20295533"/>
             <a:ext cx="10058400" cy="777240"/>
           </a:xfrm>
           <a:prstGeom prst="rect">
@@ -7852,8 +7852,8 @@
         </p:nvSpPr>
         <p:spPr>
           <a:xfrm>
-            <a:off x="22128480" y="21287232"/>
-            <a:ext cx="10332720" cy="1691640"/>
+            <a:off x="22128480" y="21200789"/>
+            <a:ext cx="10332720" cy="1757552"/>
           </a:xfrm>
           <a:prstGeom prst="rect">
             <a:avLst/>

</xml_diff>

<commit_message>
Fix bulleted text spilling below its panel
fit_height measured every paragraph against the full box width, but _bullet()
applies a hanging indent of size_pt * 1.05 to bulleted paragraphs, so they wrap
earlier than measured. The Background block came up one line short and its last
word rendered below the white panel. fit_height now subtracts the indent for
paragraphs that start with a bullet.
</commit_message>
<xml_diff>
--- a/figures/Oughton_Avilash_Angirekula_2026ASSIP_Poster.pptx
+++ b/figures/Oughton_Avilash_Angirekula_2026ASSIP_Poster.pptx
@@ -5240,7 +5240,7 @@
         <p:spPr>
           <a:xfrm>
             <a:off x="376700" y="5251774"/>
-            <a:ext cx="10282778" cy="3649979"/>
+            <a:ext cx="10282778" cy="4010723"/>
           </a:xfrm>
           <a:prstGeom prst="rect">
             <a:avLst/>
@@ -6550,7 +6550,7 @@
         </p:nvSpPr>
         <p:spPr>
           <a:xfrm>
-            <a:off x="376700" y="9247889"/>
+            <a:off x="376700" y="9500241"/>
             <a:ext cx="10282778" cy="4506023"/>
           </a:xfrm>
           <a:prstGeom prst="rect">
@@ -6596,7 +6596,7 @@
         </p:nvSpPr>
         <p:spPr>
           <a:xfrm>
-            <a:off x="376700" y="9247889"/>
+            <a:off x="376700" y="9500241"/>
             <a:ext cx="128016" cy="4506023"/>
           </a:xfrm>
           <a:prstGeom prst="rect">
@@ -6640,7 +6640,7 @@
         </p:nvSpPr>
         <p:spPr>
           <a:xfrm>
-            <a:off x="614444" y="9321041"/>
+            <a:off x="614444" y="9573393"/>
             <a:ext cx="9871298" cy="4359719"/>
           </a:xfrm>
           <a:prstGeom prst="rect">

</xml_diff>

<commit_message>
Remove the repository URL from the poster at the author's request
</commit_message>
<xml_diff>
--- a/figures/Oughton_Avilash_Angirekula_2026ASSIP_Poster.pptx
+++ b/figures/Oughton_Avilash_Angirekula_2026ASSIP_Poster.pptx
@@ -6447,7 +6447,7 @@
         <p:spPr>
           <a:xfrm>
             <a:off x="22061036" y="21636297"/>
-            <a:ext cx="10480664" cy="1620012"/>
+            <a:ext cx="10480664" cy="1215517"/>
           </a:xfrm>
           <a:prstGeom prst="rect">
             <a:avLst/>
@@ -6490,25 +6490,6 @@
               <a:cs typeface="Arial" panose="020B0604020202020204" pitchFamily="34" charset="0"/>
               <a:sym typeface="Palatino"/>
             </a:endParaRPr>
-          </a:p>
-          <a:p>
-            <a:pPr algn="l">
-              <a:lnSpc>
-                <a:spcPct val="95000"/>
-              </a:lnSpc>
-              <a:spcAft>
-                <a:spcPts val="1000"/>
-              </a:spcAft>
-            </a:pPr>
-            <a:r>
-              <a:rPr sz="2000" b="0">
-                <a:solidFill>
-                  <a:srgbClr val="333333"/>
-                </a:solidFill>
-                <a:latin typeface="Arial"/>
-              </a:rPr>
-              <a:t>Data and code: github.com/aviangirekula/datacenter-dataset</a:t>
-            </a:r>
           </a:p>
         </p:txBody>
       </p:sp>

</xml_diff>

<commit_message>
Replace an unsourced wildfire-radius justification with a measured one
I had written 'The 2.4 km radius is the 1.5 mile ember-cast distance', asserting
a specific standard the repo does not cite anywhere. The arithmetic is right
(2.4 km is 1.491 miles) but the standard was invented, the same failure as the
Pine Barrens attribution corrected earlier today.

The real justification is in the data: 2,284 of 2,696 sites sit on land the USFS
wildfire map itself classes as developed and non-burnable, so the pixel under
the building carries no information and the hazard has to be read from the
surroundings. docs/hazard_exposure.md already states this rationale.
</commit_message>
<xml_diff>
--- a/figures/Oughton_Avilash_Angirekula_2026ASSIP_Poster.pptx
+++ b/figures/Oughton_Avilash_Angirekula_2026ASSIP_Poster.pptx
@@ -7409,7 +7409,7 @@
         <p:spPr>
           <a:xfrm>
             <a:off x="376700" y="22426785"/>
-            <a:ext cx="10282778" cy="1826005"/>
+            <a:ext cx="10282778" cy="2186749"/>
           </a:xfrm>
           <a:prstGeom prst="rect">
             <a:avLst/>
@@ -7437,7 +7437,7 @@
                 </a:solidFill>
                 <a:latin typeface="Arial"/>
               </a:rPr>
-              <a:t>A site counts as exposed if it lies within 2.4 km of land rated High or Very High for wildfire, inside a FEMA Special Flood Hazard Area, or at peak ground acceleration of 0.30 g or above. The 2.4 km radius is the 1.5 mile ember-cast distance.</a:t>
+              <a:t>A site counts as exposed if it lies within 2.4 km of land rated High or Very High for wildfire, inside a FEMA Special Flood Hazard Area, or at peak ground acceleration of 0.30 g or above. Wildfire is buffered because 2,284 sites sit on land the wildfire map classes as developed, so the pixel under the building says nothing.</a:t>
             </a:r>
           </a:p>
         </p:txBody>
@@ -7853,7 +7853,7 @@
         <p:spPr>
           <a:xfrm>
             <a:off x="10965973" y="14781305"/>
-            <a:ext cx="10781748" cy="4605210"/>
+            <a:ext cx="10781748" cy="4244467"/>
           </a:xfrm>
           <a:prstGeom prst="rect">
             <a:avLst/>
@@ -7919,7 +7919,7 @@
                 </a:solidFill>
                 <a:latin typeface="Arial"/>
               </a:rPr>
-              <a:t>Widening the wildfire buffer to 5 km takes that count from 646 to 953, a 48% jump.</a:t>
+              <a:t>Widening the buffer to 5 km takes that count to 953, a 48% jump.</a:t>
             </a:r>
           </a:p>
         </p:txBody>
@@ -7940,7 +7940,7 @@
         </p:blipFill>
         <p:spPr>
           <a:xfrm>
-            <a:off x="10965973" y="19477956"/>
+            <a:off x="10965973" y="19117212"/>
             <a:ext cx="10781748" cy="4075236"/>
           </a:xfrm>
           <a:prstGeom prst="rect">
@@ -7956,7 +7956,7 @@
         </p:nvSpPr>
         <p:spPr>
           <a:xfrm>
-            <a:off x="10965973" y="23608056"/>
+            <a:off x="10965973" y="23247313"/>
             <a:ext cx="10781748" cy="688276"/>
           </a:xfrm>
           <a:prstGeom prst="rect">

</xml_diff>

<commit_message>
Fix Fig 2 dots overlapping into what looked like coloured rings
Five states sit at exactly 0.00% exposed and two at exactly 100%, so on a
single row their marks were perfectly coincident. The larger dot showed around
the smaller one and read as a ring in a second colour: California (teal, n=223)
behind New Jersey (orange, n=91) at 100%, and Virginia (grey, n=409) behind
Ohio at 0%. A reader would reasonably assume the ring encoded something.

Coincident points now settle into a beeswarm, largest first, so every state is
its own mark and no dot hides another. Labels anchor to their own dot's row
rather than the baseline.
</commit_message>
<xml_diff>
--- a/figures/Oughton_Avilash_Angirekula_2026ASSIP_Poster.pptx
+++ b/figures/Oughton_Avilash_Angirekula_2026ASSIP_Poster.pptx
@@ -7941,7 +7941,7 @@
         <p:spPr>
           <a:xfrm>
             <a:off x="10965973" y="20087218"/>
-            <a:ext cx="10781748" cy="3410141"/>
+            <a:ext cx="10781748" cy="3471997"/>
           </a:xfrm>
           <a:prstGeom prst="rect">
             <a:avLst/>
@@ -7956,7 +7956,7 @@
         </p:nvSpPr>
         <p:spPr>
           <a:xfrm>
-            <a:off x="10965973" y="23552223"/>
+            <a:off x="10965973" y="23614079"/>
             <a:ext cx="10781748" cy="688276"/>
           </a:xfrm>
           <a:prstGeom prst="rect">

</xml_diff>

<commit_message>
Pack Fig 2 as a true circle beeswarm so no dot hides another
The first beeswarm attempt still overlapped. Its collision test compared both
axes against the same fudge factor, but the axes are about 740 pt wide across
112 percentage points and only about 150 pt tall across the y range, so a data
unit is worth roughly seven times more vertically than horizontally. Dots that
tested as clear were still touching.

Packing is now done in point space with a real circle-to-circle distance test,
largest first, each dot dropped to the lowest free height. Verified: the closest
pair clears by 1.64 pt. The y range is derived from the resulting stack rather
than fixed in advance, and labels are anchored above every packed dot in two
bands, with a horizontal nudge where two labelled states sit close enough that a
leader line would cross the other's text. Marker area reduced so the stack and
its label bands fit the column.
</commit_message>
<xml_diff>
--- a/figures/Oughton_Avilash_Angirekula_2026ASSIP_Poster.pptx
+++ b/figures/Oughton_Avilash_Angirekula_2026ASSIP_Poster.pptx
@@ -7941,7 +7941,7 @@
         <p:spPr>
           <a:xfrm>
             <a:off x="10965973" y="20087218"/>
-            <a:ext cx="10781748" cy="3471997"/>
+            <a:ext cx="10781748" cy="3673701"/>
           </a:xfrm>
           <a:prstGeom prst="rect">
             <a:avLst/>
@@ -7956,7 +7956,7 @@
         </p:nvSpPr>
         <p:spPr>
           <a:xfrm>
-            <a:off x="10965973" y="23614079"/>
+            <a:off x="10965973" y="23815783"/>
             <a:ext cx="10781748" cy="688276"/>
           </a:xfrm>
           <a:prstGeom prst="rect">

</xml_diff>

<commit_message>
Replace Fig 2's dot plot with a facility-weighted histogram
The beeswarm solved overlap by stacking dots vertically, but that height
encoded nothing while looking like it did. A reader four feet away sees marks
at different heights and reasonably assumes the position means something.

A histogram has no such axis to misread: height is facilities, width is a
10-point exposure band, and no mark can occlude another. It also shows the
bimodality rather than asserting it in a caption. 1,294 facilities sit in
states under 10% exposed and 485 in states above 90%, with 21 in the 50-60%
band.

Bars are stacked by which hazard drives each state, with one correction: for a
state at 0.7% exposed the dominant hazard is the argmax of three near-zero
numbers, so Virginia's 409 facilities were being coloured flood-driven. States
under 1% now carry their own grey category, matching how Figure 1 uses grey.
</commit_message>
<xml_diff>
--- a/figures/Oughton_Avilash_Angirekula_2026ASSIP_Poster.pptx
+++ b/figures/Oughton_Avilash_Angirekula_2026ASSIP_Poster.pptx
@@ -7941,7 +7941,7 @@
         <p:spPr>
           <a:xfrm>
             <a:off x="10965973" y="20087218"/>
-            <a:ext cx="10781748" cy="3673701"/>
+            <a:ext cx="10781748" cy="3372490"/>
           </a:xfrm>
           <a:prstGeom prst="rect">
             <a:avLst/>
@@ -7956,7 +7956,7 @@
         </p:nvSpPr>
         <p:spPr>
           <a:xfrm>
-            <a:off x="10965973" y="23815783"/>
+            <a:off x="10965973" y="23514572"/>
             <a:ext cx="10781748" cy="688276"/>
           </a:xfrm>
           <a:prstGeom prst="rect">
@@ -7985,7 +7985,7 @@
                 </a:solidFill>
                 <a:latin typeface="Arial"/>
               </a:rPr>
-              <a:t>Fig 2. All 32 states with 20 or more sites, coloured by dominant hazard.</a:t>
+              <a:t>Fig 2. The fleet piles up at both ends. Colour shows which hazard drives each state.</a:t>
             </a:r>
           </a:p>
         </p:txBody>

</xml_diff>